<commit_message>
Add per-SKU PPT: 2026-08-24_H0883003_S_BASF4719873980017.pptx
</commit_message>
<xml_diff>
--- a/ppt/2026-08-24_H0883003_S_BASF4719873980017.pptx
+++ b/ppt/2026-08-24_H0883003_S_BASF4719873980017.pptx
@@ -1156,7 +1156,7 @@
                 <a:ea typeface="Arial Black" pitchFamily="34" charset="-122"/>
                 <a:cs typeface="Arial Black" pitchFamily="34" charset="-120"/>
               </a:rPr>
-              <a:t>10</a:t>
+              <a:t>7</a:t>
             </a:r>
             <a:endParaRPr lang="en-US" sz="4000" dirty="0"/>
           </a:p>
@@ -1195,7 +1195,7 @@
                 <a:ea typeface="Microsoft JhengHei" pitchFamily="34" charset="-122"/>
                 <a:cs typeface="Microsoft JhengHei" pitchFamily="34" charset="-120"/>
               </a:rPr>
-              <a:t>一點絕 2％凝膠餌劑 5g</a:t>
+              <a:t>一點絕 2％凝膠餌劑 5g ▼A1(80017)(平行進口)</a:t>
             </a:r>
             <a:endParaRPr lang="en-US" sz="2500" dirty="0"/>
           </a:p>
@@ -1533,7 +1533,7 @@
                 <a:ea typeface="Arial Black" pitchFamily="34" charset="-122"/>
                 <a:cs typeface="Arial Black" pitchFamily="34" charset="-120"/>
               </a:rPr>
-              <a:t>$19,204</a:t>
+              <a:t>$19,203.65</a:t>
             </a:r>
             <a:endParaRPr lang="en-US" sz="1600" dirty="0"/>
           </a:p>
@@ -1855,7 +1855,7 @@
                 <a:ea typeface="Microsoft JhengHei" pitchFamily="34" charset="-122"/>
                 <a:cs typeface="Microsoft JhengHei" pitchFamily="34" charset="-120"/>
               </a:rPr>
-              <a:t>📢 一點絕滅蟑影片（使用說明 7 年前；滅蟑法寶 5 年前）— 夏季滅蟑季節性話題</a:t>
+              <a:t>📢 一點絕滅蟑影片（5個月前餌盒教學；7年前使用說明）— 夏季滅蟑季節性話題</a:t>
             </a:r>
             <a:endParaRPr lang="en-US" sz="950" dirty="0"/>
           </a:p>
@@ -1903,7 +1903,7 @@
                   </a:extLst>
                 </a:hlinkClick>
               </a:rPr>
-              <a:t>📺 https://www.youtube.com/watch?v=JjSpCYIykuQ</a:t>
+              <a:t>📺 https://www.youtube.com/watch?v=GpVDzGAUCkA</a:t>
             </a:r>
             <a:endParaRPr lang="en-US" sz="900" dirty="0"/>
           </a:p>

</xml_diff>